<commit_message>
added some slides to PowerPoint
</commit_message>
<xml_diff>
--- a/ShareWay.pptx
+++ b/ShareWay.pptx
@@ -12,6 +12,8 @@
     <p:sldId id="259" r:id="rId6"/>
     <p:sldId id="261" r:id="rId7"/>
     <p:sldId id="262" r:id="rId8"/>
+    <p:sldId id="263" r:id="rId9"/>
+    <p:sldId id="264" r:id="rId10"/>
   </p:sldIdLst>
   <p:sldSz cx="12192000" cy="6858000"/>
   <p:notesSz cx="6858000" cy="9144000"/>
@@ -110,7 +112,55 @@
       </a:defRPr>
     </a:lvl9pPr>
   </p:defaultTextStyle>
+  <p:extLst>
+    <p:ext uri="{EFAFB233-063F-42B5-8137-9DF3F51BA10A}">
+      <p15:sldGuideLst xmlns:p15="http://schemas.microsoft.com/office/powerpoint/2012/main"/>
+    </p:ext>
+  </p:extLst>
 </p:presentation>
+</file>
+
+<file path=ppt/changesInfos/changesInfo1.xml><?xml version="1.0" encoding="utf-8"?>
+<pc:chgInfo xmlns:a="http://schemas.openxmlformats.org/drawingml/2006/main" xmlns:r="http://schemas.openxmlformats.org/officeDocument/2006/relationships" xmlns:ac="http://schemas.microsoft.com/office/drawing/2013/main/command" xmlns:pc="http://schemas.microsoft.com/office/powerpoint/2013/main/command">
+  <pc:docChgLst>
+    <pc:chgData name="Sascha Berger" userId="7f8a0270a796afee" providerId="LiveId" clId="{E45ADAD5-F223-44C1-BBC5-7CBF4EC27ACF}"/>
+    <pc:docChg chg="addSld modSld">
+      <pc:chgData name="Sascha Berger" userId="7f8a0270a796afee" providerId="LiveId" clId="{E45ADAD5-F223-44C1-BBC5-7CBF4EC27ACF}" dt="2026-09-15T09:07:00.553" v="41" actId="20577"/>
+      <pc:docMkLst>
+        <pc:docMk/>
+      </pc:docMkLst>
+      <pc:sldChg chg="modSp mod">
+        <pc:chgData name="Sascha Berger" userId="7f8a0270a796afee" providerId="LiveId" clId="{E45ADAD5-F223-44C1-BBC5-7CBF4EC27ACF}" dt="2026-09-15T09:07:00.553" v="41" actId="20577"/>
+        <pc:sldMkLst>
+          <pc:docMk/>
+          <pc:sldMk cId="3576835308" sldId="256"/>
+        </pc:sldMkLst>
+        <pc:spChg chg="mod">
+          <ac:chgData name="Sascha Berger" userId="7f8a0270a796afee" providerId="LiveId" clId="{E45ADAD5-F223-44C1-BBC5-7CBF4EC27ACF}" dt="2026-09-15T09:07:00.553" v="41" actId="20577"/>
+          <ac:spMkLst>
+            <pc:docMk/>
+            <pc:sldMk cId="3576835308" sldId="256"/>
+            <ac:spMk id="3" creationId="{4F3F85EC-2D4B-08C2-CD55-FE2147060B4E}"/>
+          </ac:spMkLst>
+        </pc:spChg>
+      </pc:sldChg>
+      <pc:sldChg chg="new">
+        <pc:chgData name="Sascha Berger" userId="7f8a0270a796afee" providerId="LiveId" clId="{E45ADAD5-F223-44C1-BBC5-7CBF4EC27ACF}" dt="2026-09-15T09:06:06.173" v="0" actId="680"/>
+        <pc:sldMkLst>
+          <pc:docMk/>
+          <pc:sldMk cId="4164614883" sldId="263"/>
+        </pc:sldMkLst>
+      </pc:sldChg>
+      <pc:sldChg chg="new">
+        <pc:chgData name="Sascha Berger" userId="7f8a0270a796afee" providerId="LiveId" clId="{E45ADAD5-F223-44C1-BBC5-7CBF4EC27ACF}" dt="2026-09-15T09:06:07.973" v="1" actId="680"/>
+        <pc:sldMkLst>
+          <pc:docMk/>
+          <pc:sldMk cId="2654491127" sldId="264"/>
+        </pc:sldMkLst>
+      </pc:sldChg>
+    </pc:docChg>
+  </pc:docChgLst>
+</pc:chgInfo>
 </file>
 
 <file path=ppt/slideLayouts/slideLayout1.xml><?xml version="1.0" encoding="utf-8"?>
@@ -262,7 +312,7 @@
           <a:p>
             <a:fld id="{DFB40290-68C0-4B12-9600-8A3DABB019B8}" type="datetimeFigureOut">
               <a:rPr lang="de-AT" smtClean="0"/>
-              <a:t>11.09.2026</a:t>
+              <a:t>15.09.2026</a:t>
             </a:fld>
             <a:endParaRPr lang="de-AT"/>
           </a:p>
@@ -462,7 +512,7 @@
           <a:p>
             <a:fld id="{DFB40290-68C0-4B12-9600-8A3DABB019B8}" type="datetimeFigureOut">
               <a:rPr lang="de-AT" smtClean="0"/>
-              <a:t>11.09.2026</a:t>
+              <a:t>15.09.2026</a:t>
             </a:fld>
             <a:endParaRPr lang="de-AT"/>
           </a:p>
@@ -672,7 +722,7 @@
           <a:p>
             <a:fld id="{DFB40290-68C0-4B12-9600-8A3DABB019B8}" type="datetimeFigureOut">
               <a:rPr lang="de-AT" smtClean="0"/>
-              <a:t>11.09.2026</a:t>
+              <a:t>15.09.2026</a:t>
             </a:fld>
             <a:endParaRPr lang="de-AT"/>
           </a:p>
@@ -872,7 +922,7 @@
           <a:p>
             <a:fld id="{DFB40290-68C0-4B12-9600-8A3DABB019B8}" type="datetimeFigureOut">
               <a:rPr lang="de-AT" smtClean="0"/>
-              <a:t>11.09.2026</a:t>
+              <a:t>15.09.2026</a:t>
             </a:fld>
             <a:endParaRPr lang="de-AT"/>
           </a:p>
@@ -1148,7 +1198,7 @@
           <a:p>
             <a:fld id="{DFB40290-68C0-4B12-9600-8A3DABB019B8}" type="datetimeFigureOut">
               <a:rPr lang="de-AT" smtClean="0"/>
-              <a:t>11.09.2026</a:t>
+              <a:t>15.09.2026</a:t>
             </a:fld>
             <a:endParaRPr lang="de-AT"/>
           </a:p>
@@ -1416,7 +1466,7 @@
           <a:p>
             <a:fld id="{DFB40290-68C0-4B12-9600-8A3DABB019B8}" type="datetimeFigureOut">
               <a:rPr lang="de-AT" smtClean="0"/>
-              <a:t>11.09.2026</a:t>
+              <a:t>15.09.2026</a:t>
             </a:fld>
             <a:endParaRPr lang="de-AT"/>
           </a:p>
@@ -1831,7 +1881,7 @@
           <a:p>
             <a:fld id="{DFB40290-68C0-4B12-9600-8A3DABB019B8}" type="datetimeFigureOut">
               <a:rPr lang="de-AT" smtClean="0"/>
-              <a:t>11.09.2026</a:t>
+              <a:t>15.09.2026</a:t>
             </a:fld>
             <a:endParaRPr lang="de-AT"/>
           </a:p>
@@ -1973,7 +2023,7 @@
           <a:p>
             <a:fld id="{DFB40290-68C0-4B12-9600-8A3DABB019B8}" type="datetimeFigureOut">
               <a:rPr lang="de-AT" smtClean="0"/>
-              <a:t>11.09.2026</a:t>
+              <a:t>15.09.2026</a:t>
             </a:fld>
             <a:endParaRPr lang="de-AT"/>
           </a:p>
@@ -2086,7 +2136,7 @@
           <a:p>
             <a:fld id="{DFB40290-68C0-4B12-9600-8A3DABB019B8}" type="datetimeFigureOut">
               <a:rPr lang="de-AT" smtClean="0"/>
-              <a:t>11.09.2026</a:t>
+              <a:t>15.09.2026</a:t>
             </a:fld>
             <a:endParaRPr lang="de-AT"/>
           </a:p>
@@ -2399,7 +2449,7 @@
           <a:p>
             <a:fld id="{DFB40290-68C0-4B12-9600-8A3DABB019B8}" type="datetimeFigureOut">
               <a:rPr lang="de-AT" smtClean="0"/>
-              <a:t>11.09.2026</a:t>
+              <a:t>15.09.2026</a:t>
             </a:fld>
             <a:endParaRPr lang="de-AT"/>
           </a:p>
@@ -2688,7 +2738,7 @@
           <a:p>
             <a:fld id="{DFB40290-68C0-4B12-9600-8A3DABB019B8}" type="datetimeFigureOut">
               <a:rPr lang="de-AT" smtClean="0"/>
-              <a:t>11.09.2026</a:t>
+              <a:t>15.09.2026</a:t>
             </a:fld>
             <a:endParaRPr lang="de-AT"/>
           </a:p>
@@ -2931,7 +2981,7 @@
           <a:p>
             <a:fld id="{DFB40290-68C0-4B12-9600-8A3DABB019B8}" type="datetimeFigureOut">
               <a:rPr lang="de-AT" smtClean="0"/>
-              <a:t>11.09.2026</a:t>
+              <a:t>15.09.2026</a:t>
             </a:fld>
             <a:endParaRPr lang="de-AT"/>
           </a:p>
@@ -3399,8 +3449,13 @@
           <a:p>
             <a:r>
               <a:rPr lang="de-AT" dirty="0"/>
-              <a:t>Berger, Miniböck</a:t>
-            </a:r>
+              <a:t>Miniböck Martin, </a:t>
+            </a:r>
+            <a:r>
+              <a:rPr lang="de-AT"/>
+              <a:t>Berger Sascha</a:t>
+            </a:r>
+            <a:endParaRPr lang="de-AT" dirty="0"/>
           </a:p>
         </p:txBody>
       </p:sp>
@@ -3924,6 +3979,166 @@
     <p:extLst>
       <p:ext uri="{BB962C8B-B14F-4D97-AF65-F5344CB8AC3E}">
         <p14:creationId xmlns:p14="http://schemas.microsoft.com/office/powerpoint/2010/main" val="4122102523"/>
+      </p:ext>
+    </p:extLst>
+  </p:cSld>
+  <p:clrMapOvr>
+    <a:masterClrMapping/>
+  </p:clrMapOvr>
+</p:sld>
+</file>
+
+<file path=ppt/slides/slide8.xml><?xml version="1.0" encoding="utf-8"?>
+<p:sld xmlns:a="http://schemas.openxmlformats.org/drawingml/2006/main" xmlns:r="http://schemas.openxmlformats.org/officeDocument/2006/relationships" xmlns:p="http://schemas.openxmlformats.org/presentationml/2006/main">
+  <p:cSld>
+    <p:spTree>
+      <p:nvGrpSpPr>
+        <p:cNvPr id="1" name=""/>
+        <p:cNvGrpSpPr/>
+        <p:nvPr/>
+      </p:nvGrpSpPr>
+      <p:grpSpPr>
+        <a:xfrm>
+          <a:off x="0" y="0"/>
+          <a:ext cx="0" cy="0"/>
+          <a:chOff x="0" y="0"/>
+          <a:chExt cx="0" cy="0"/>
+        </a:xfrm>
+      </p:grpSpPr>
+      <p:sp>
+        <p:nvSpPr>
+          <p:cNvPr id="2" name="Titel 1">
+            <a:extLst>
+              <a:ext uri="{FF2B5EF4-FFF2-40B4-BE49-F238E27FC236}">
+                <a16:creationId xmlns:a16="http://schemas.microsoft.com/office/drawing/2014/main" id="{4042199A-5008-8742-E731-D6F06F980508}"/>
+              </a:ext>
+            </a:extLst>
+          </p:cNvPr>
+          <p:cNvSpPr>
+            <a:spLocks noGrp="1"/>
+          </p:cNvSpPr>
+          <p:nvPr>
+            <p:ph type="title"/>
+          </p:nvPr>
+        </p:nvSpPr>
+        <p:spPr/>
+        <p:txBody>
+          <a:bodyPr/>
+          <a:lstStyle/>
+          <a:p>
+            <a:endParaRPr lang="de-AT"/>
+          </a:p>
+        </p:txBody>
+      </p:sp>
+      <p:sp>
+        <p:nvSpPr>
+          <p:cNvPr id="3" name="Inhaltsplatzhalter 2">
+            <a:extLst>
+              <a:ext uri="{FF2B5EF4-FFF2-40B4-BE49-F238E27FC236}">
+                <a16:creationId xmlns:a16="http://schemas.microsoft.com/office/drawing/2014/main" id="{808BB442-9668-0DA8-61ED-3C3683A5BFB7}"/>
+              </a:ext>
+            </a:extLst>
+          </p:cNvPr>
+          <p:cNvSpPr>
+            <a:spLocks noGrp="1"/>
+          </p:cNvSpPr>
+          <p:nvPr>
+            <p:ph idx="1"/>
+          </p:nvPr>
+        </p:nvSpPr>
+        <p:spPr/>
+        <p:txBody>
+          <a:bodyPr/>
+          <a:lstStyle/>
+          <a:p>
+            <a:endParaRPr lang="de-AT"/>
+          </a:p>
+        </p:txBody>
+      </p:sp>
+    </p:spTree>
+    <p:extLst>
+      <p:ext uri="{BB962C8B-B14F-4D97-AF65-F5344CB8AC3E}">
+        <p14:creationId xmlns:p14="http://schemas.microsoft.com/office/powerpoint/2010/main" val="4164614883"/>
+      </p:ext>
+    </p:extLst>
+  </p:cSld>
+  <p:clrMapOvr>
+    <a:masterClrMapping/>
+  </p:clrMapOvr>
+</p:sld>
+</file>
+
+<file path=ppt/slides/slide9.xml><?xml version="1.0" encoding="utf-8"?>
+<p:sld xmlns:a="http://schemas.openxmlformats.org/drawingml/2006/main" xmlns:r="http://schemas.openxmlformats.org/officeDocument/2006/relationships" xmlns:p="http://schemas.openxmlformats.org/presentationml/2006/main">
+  <p:cSld>
+    <p:spTree>
+      <p:nvGrpSpPr>
+        <p:cNvPr id="1" name=""/>
+        <p:cNvGrpSpPr/>
+        <p:nvPr/>
+      </p:nvGrpSpPr>
+      <p:grpSpPr>
+        <a:xfrm>
+          <a:off x="0" y="0"/>
+          <a:ext cx="0" cy="0"/>
+          <a:chOff x="0" y="0"/>
+          <a:chExt cx="0" cy="0"/>
+        </a:xfrm>
+      </p:grpSpPr>
+      <p:sp>
+        <p:nvSpPr>
+          <p:cNvPr id="2" name="Titel 1">
+            <a:extLst>
+              <a:ext uri="{FF2B5EF4-FFF2-40B4-BE49-F238E27FC236}">
+                <a16:creationId xmlns:a16="http://schemas.microsoft.com/office/drawing/2014/main" id="{5F5954C3-F678-532F-CE53-51F8E76FABA4}"/>
+              </a:ext>
+            </a:extLst>
+          </p:cNvPr>
+          <p:cNvSpPr>
+            <a:spLocks noGrp="1"/>
+          </p:cNvSpPr>
+          <p:nvPr>
+            <p:ph type="title"/>
+          </p:nvPr>
+        </p:nvSpPr>
+        <p:spPr/>
+        <p:txBody>
+          <a:bodyPr/>
+          <a:lstStyle/>
+          <a:p>
+            <a:endParaRPr lang="de-AT"/>
+          </a:p>
+        </p:txBody>
+      </p:sp>
+      <p:sp>
+        <p:nvSpPr>
+          <p:cNvPr id="3" name="Inhaltsplatzhalter 2">
+            <a:extLst>
+              <a:ext uri="{FF2B5EF4-FFF2-40B4-BE49-F238E27FC236}">
+                <a16:creationId xmlns:a16="http://schemas.microsoft.com/office/drawing/2014/main" id="{87B2DDAD-14AA-7DF3-C9A3-560B096AA4B1}"/>
+              </a:ext>
+            </a:extLst>
+          </p:cNvPr>
+          <p:cNvSpPr>
+            <a:spLocks noGrp="1"/>
+          </p:cNvSpPr>
+          <p:nvPr>
+            <p:ph idx="1"/>
+          </p:nvPr>
+        </p:nvSpPr>
+        <p:spPr/>
+        <p:txBody>
+          <a:bodyPr/>
+          <a:lstStyle/>
+          <a:p>
+            <a:endParaRPr lang="de-AT"/>
+          </a:p>
+        </p:txBody>
+      </p:sp>
+    </p:spTree>
+    <p:extLst>
+      <p:ext uri="{BB962C8B-B14F-4D97-AF65-F5344CB8AC3E}">
+        <p14:creationId xmlns:p14="http://schemas.microsoft.com/office/powerpoint/2010/main" val="2654491127"/>
       </p:ext>
     </p:extLst>
   </p:cSld>

</xml_diff>